<commit_message>
fix: generate validated confusion matrix in results deck
</commit_message>
<xml_diff>
--- a/data/model/random-forest-results.pptx
+++ b/data/model/random-forest-results.pptx
@@ -3533,7 +3533,7 @@
                 </a:solidFill>
                 <a:latin typeface="Microsoft JhengHei"/>
               </a:rPr>
-              <a:t>各強度 Recall / support</a:t>
+              <a:t>各震度 Recall / support</a:t>
             </a:r>
           </a:p>
         </p:txBody>
@@ -3567,7 +3567,7 @@
                 </a:solidFill>
                 <a:latin typeface="Microsoft JhengHei"/>
               </a:rPr>
-              <a:t>強度 0：0.0%（support 1）</a:t>
+              <a:t>震度 0：0.0%（support 1）</a:t>
             </a:r>
           </a:p>
         </p:txBody>
@@ -3601,7 +3601,7 @@
                 </a:solidFill>
                 <a:latin typeface="Microsoft JhengHei"/>
               </a:rPr>
-              <a:t>強度 1：19.4%（support 289）</a:t>
+              <a:t>震度 1：19.4%（support 289）</a:t>
             </a:r>
           </a:p>
         </p:txBody>
@@ -3635,7 +3635,7 @@
                 </a:solidFill>
                 <a:latin typeface="Microsoft JhengHei"/>
               </a:rPr>
-              <a:t>強度 2：43.2%（support 1,278）</a:t>
+              <a:t>震度 2：43.2%（support 1,278）</a:t>
             </a:r>
           </a:p>
         </p:txBody>
@@ -3669,7 +3669,7 @@
                 </a:solidFill>
                 <a:latin typeface="Microsoft JhengHei"/>
               </a:rPr>
-              <a:t>強度 3：39.8%（support 910）</a:t>
+              <a:t>震度 3：39.8%（support 910）</a:t>
             </a:r>
           </a:p>
         </p:txBody>
@@ -3703,7 +3703,7 @@
                 </a:solidFill>
                 <a:latin typeface="Microsoft JhengHei"/>
               </a:rPr>
-              <a:t>強度 4：64.9%（support 538）</a:t>
+              <a:t>震度 4：64.9%（support 538）</a:t>
             </a:r>
           </a:p>
         </p:txBody>
@@ -3737,7 +3737,7 @@
                 </a:solidFill>
                 <a:latin typeface="Microsoft JhengHei"/>
               </a:rPr>
-              <a:t>強度 5：68.4%（support 19）</a:t>
+              <a:t>震度 5：68.4%（support 19）</a:t>
             </a:r>
           </a:p>
         </p:txBody>
@@ -3771,7 +3771,7 @@
                 </a:solidFill>
                 <a:latin typeface="Microsoft JhengHei"/>
               </a:rPr>
-              <a:t>強度 6：50.0%（support 4）</a:t>
+              <a:t>震度 6：50.0%（support 4）</a:t>
             </a:r>
           </a:p>
         </p:txBody>
@@ -3805,7 +3805,7 @@
                 </a:solidFill>
                 <a:latin typeface="Microsoft JhengHei"/>
               </a:rPr>
-              <a:t>強度 7：N/A（support 0）</a:t>
+              <a:t>震度 7：N/A（support 0）</a:t>
             </a:r>
           </a:p>
         </p:txBody>
@@ -3919,7 +3919,7 @@
                 </a:solidFill>
                 <a:latin typeface="Microsoft JhengHei"/>
               </a:rPr>
-              <a:t>稀有類別警告：測試集強度 0 僅 1 筆、強度 6 僅 4 筆、強度 7 為 0 筆；相關 Recall 不宜視為穩定結論。</a:t>
+              <a:t>稀有類別警告：測試集震度 0 僅 1 筆、震度 6 僅 4 筆、震度 7 為 0 筆；相關 Recall 不宜視為穩定結論。</a:t>
             </a:r>
           </a:p>
         </p:txBody>
@@ -4065,7 +4065,7 @@
       </p:sp>
       <p:pic>
         <p:nvPicPr>
-          <p:cNvPr id="5" name="Picture 4" descr="random_forest_confusion_matrix.png"/>
+          <p:cNvPr id="5" name="Picture 4" descr="image.png"/>
           <p:cNvPicPr>
             <a:picLocks noChangeAspect="1"/>
           </p:cNvPicPr>
@@ -4079,8 +4079,8 @@
         </p:blipFill>
         <p:spPr>
           <a:xfrm>
-            <a:off x="881742" y="1078992"/>
-            <a:ext cx="6877594" cy="5349240"/>
+            <a:off x="754380" y="1078992"/>
+            <a:ext cx="7132319" cy="5349240"/>
           </a:xfrm>
           <a:prstGeom prst="rect">
             <a:avLst/>

</xml_diff>